<commit_message>
Weekly report 2026-W38.md（GitHub Actions）
</commit_message>
<xml_diff>
--- a/data/reports/2026-W38.pptx
+++ b/data/reports/2026-W38.pptx
@@ -11,6 +11,7 @@
     <p:sldId id="259" r:id="rId10"/>
     <p:sldId id="260" r:id="rId11"/>
     <p:sldId id="261" r:id="rId12"/>
+    <p:sldId id="262" r:id="rId13"/>
   </p:sldIdLst>
   <p:sldSz cx="12191695" cy="6858000" type="screen4x3"/>
   <p:notesSz cx="6858000" cy="9144000"/>
@@ -3447,7 +3448,7 @@
         <p:spPr>
           <a:xfrm>
             <a:off x="868680" y="1600200"/>
-            <a:ext cx="10698480" cy="877824"/>
+            <a:ext cx="10698480" cy="1115568"/>
           </a:xfrm>
           <a:prstGeom prst="rect">
             <a:avLst/>
@@ -3472,7 +3473,7 @@
                 </a:solidFill>
                 <a:latin typeface="Arial"/>
               </a:rPr>
-              <a:t>這週投影機產業聚焦於B端市場跨界應用與上游供應鏈轉變。極米科技以高穩定性開拓文化展演市場，Epson大型雷射投影機則將歌劇字幕轉化為動態舞台藝術；同時，矽光子技術的光學模組生產瓶頸正向上游雷射級基板供應轉移，突顯上游原材料的關鍵地位。</a:t>
+              <a:t>這週投影機產業聚焦於高階應用與供應鏈轉型，其中極米科技於成都雙年展達成 196 天零故障，成功展現消費品牌跨足 B 端文化展演市場的潛力。同時，上游矽光子光學模組的生產瓶頸已自元件製造端向上游雷射級基板供應轉移，而各大品牌如當貝、科視與 soundcore Nebula 也紛紛發表高階雷射投影與智慧投影新品，持續拓展多元應用場景。</a:t>
             </a:r>
           </a:p>
         </p:txBody>
@@ -3610,27 +3611,23 @@
       </p:sp>
       <p:sp>
         <p:nvSpPr>
-          <p:cNvPr id="4" name="Rounded Rectangle 3"/>
+          <p:cNvPr id="4" name="Oval 3"/>
           <p:cNvSpPr/>
           <p:nvPr/>
         </p:nvSpPr>
         <p:spPr>
           <a:xfrm>
-            <a:off x="548640" y="1600200"/>
-            <a:ext cx="3545738" cy="4754880"/>
-          </a:xfrm>
-          <a:prstGeom prst="roundRect">
-            <a:avLst>
-              <a:gd name="adj" fmla="val 6000"/>
-            </a:avLst>
+            <a:off x="594360" y="1728216"/>
+            <a:ext cx="100584" cy="100584"/>
+          </a:xfrm>
+          <a:prstGeom prst="ellipse">
+            <a:avLst/>
           </a:prstGeom>
           <a:solidFill>
-            <a:srgbClr val="23262F"/>
+            <a:srgbClr val="4C7EFF"/>
           </a:solidFill>
-          <a:ln w="12700">
-            <a:solidFill>
-              <a:srgbClr val="4C7EFF"/>
-            </a:solidFill>
+          <a:ln>
+            <a:noFill/>
           </a:ln>
           <a:effectLst/>
         </p:spPr>
@@ -3664,43 +3661,8 @@
         </p:nvSpPr>
         <p:spPr>
           <a:xfrm>
-            <a:off x="749808" y="1764792"/>
-            <a:ext cx="3143402" cy="457200"/>
-          </a:xfrm>
-          <a:prstGeom prst="rect">
-            <a:avLst/>
-          </a:prstGeom>
-          <a:noFill/>
-        </p:spPr>
-        <p:txBody>
-          <a:bodyPr wrap="square" anchor="t">
-            <a:spAutoFit/>
-          </a:bodyPr>
-          <a:lstStyle/>
-          <a:p>
-            <a:pPr algn="l"/>
-            <a:r>
-              <a:rPr sz="1450" b="1">
-                <a:solidFill>
-                  <a:srgbClr val="4C7EFF"/>
-                </a:solidFill>
-                <a:latin typeface="Arial"/>
-              </a:rPr>
-              <a:t>消費品牌跨足藝文展演</a:t>
-            </a:r>
-          </a:p>
-        </p:txBody>
-      </p:sp>
-      <p:sp>
-        <p:nvSpPr>
-          <p:cNvPr id="6" name="TextBox 5"/>
-          <p:cNvSpPr txBox="1"/>
-          <p:nvPr/>
-        </p:nvSpPr>
-        <p:spPr>
-          <a:xfrm>
-            <a:off x="749808" y="2258568"/>
-            <a:ext cx="3143402" cy="3931920"/>
+            <a:off x="868680" y="1600200"/>
+            <a:ext cx="10698480" cy="640080"/>
           </a:xfrm>
           <a:prstGeom prst="rect">
             <a:avLst/>
@@ -3715,44 +3677,49 @@
           <a:p>
             <a:pPr>
               <a:lnSpc>
-                <a:spcPct val="120000"/>
+                <a:spcPct val="115000"/>
               </a:lnSpc>
             </a:pPr>
             <a:r>
-              <a:rPr sz="1150">
-                <a:solidFill>
-                  <a:srgbClr val="F5F3EC"/>
+              <a:rPr sz="1450" b="1">
+                <a:solidFill>
+                  <a:srgbClr val="FFB454"/>
                 </a:solidFill>
                 <a:latin typeface="Arial"/>
               </a:rPr>
-              <a:t>極米科技70台投影設備在成都雙年展196天展期中達成零故障運行，獲成都市美術館感謝函，成功開闢客廳以外的B端文化藝術場景（投影時代）。</a:t>
-            </a:r>
-          </a:p>
-        </p:txBody>
-      </p:sp>
-      <p:sp>
-        <p:nvSpPr>
-          <p:cNvPr id="7" name="Rounded Rectangle 6"/>
+              <a:t>消費品牌跨足 B 端展演</a:t>
+            </a:r>
+            <a:r>
+              <a:rPr sz="1450">
+                <a:solidFill>
+                  <a:srgbClr val="F5F3EC"/>
+                </a:solidFill>
+                <a:latin typeface="Arial"/>
+              </a:rPr>
+              <a:t>：極米科技 70 台投影設備在成都雙年展 196 天展期中達成零故障運行，獲成都市美術館感謝函，開闢客廳以外的 B 端業務戰場（投影時代）。</a:t>
+            </a:r>
+          </a:p>
+        </p:txBody>
+      </p:sp>
+      <p:sp>
+        <p:nvSpPr>
+          <p:cNvPr id="6" name="Oval 5"/>
           <p:cNvSpPr/>
           <p:nvPr/>
         </p:nvSpPr>
         <p:spPr>
           <a:xfrm>
-            <a:off x="4322978" y="1600200"/>
-            <a:ext cx="3545738" cy="4754880"/>
-          </a:xfrm>
-          <a:prstGeom prst="roundRect">
-            <a:avLst>
-              <a:gd name="adj" fmla="val 6000"/>
-            </a:avLst>
+            <a:off x="594360" y="2368296"/>
+            <a:ext cx="100584" cy="100584"/>
+          </a:xfrm>
+          <a:prstGeom prst="ellipse">
+            <a:avLst/>
           </a:prstGeom>
           <a:solidFill>
-            <a:srgbClr val="23262F"/>
+            <a:srgbClr val="4C7EFF"/>
           </a:solidFill>
-          <a:ln w="12700">
-            <a:solidFill>
-              <a:srgbClr val="FFB454"/>
-            </a:solidFill>
+          <a:ln>
+            <a:noFill/>
           </a:ln>
           <a:effectLst/>
         </p:spPr>
@@ -3780,49 +3747,14 @@
       </p:sp>
       <p:sp>
         <p:nvSpPr>
-          <p:cNvPr id="8" name="TextBox 7"/>
+          <p:cNvPr id="7" name="TextBox 6"/>
           <p:cNvSpPr txBox="1"/>
           <p:nvPr/>
         </p:nvSpPr>
         <p:spPr>
           <a:xfrm>
-            <a:off x="4524146" y="1764792"/>
-            <a:ext cx="3143402" cy="457200"/>
-          </a:xfrm>
-          <a:prstGeom prst="rect">
-            <a:avLst/>
-          </a:prstGeom>
-          <a:noFill/>
-        </p:spPr>
-        <p:txBody>
-          <a:bodyPr wrap="square" anchor="t">
-            <a:spAutoFit/>
-          </a:bodyPr>
-          <a:lstStyle/>
-          <a:p>
-            <a:pPr algn="l"/>
-            <a:r>
-              <a:rPr sz="1450" b="1">
-                <a:solidFill>
-                  <a:srgbClr val="FFB454"/>
-                </a:solidFill>
-                <a:latin typeface="Arial"/>
-              </a:rPr>
-              <a:t>高階與智慧投影新品齊發</a:t>
-            </a:r>
-          </a:p>
-        </p:txBody>
-      </p:sp>
-      <p:sp>
-        <p:nvSpPr>
-          <p:cNvPr id="9" name="TextBox 8"/>
-          <p:cNvSpPr txBox="1"/>
-          <p:nvPr/>
-        </p:nvSpPr>
-        <p:spPr>
-          <a:xfrm>
-            <a:off x="4524146" y="2258568"/>
-            <a:ext cx="3143402" cy="3931920"/>
+            <a:off x="868680" y="2240280"/>
+            <a:ext cx="10698480" cy="402336"/>
           </a:xfrm>
           <a:prstGeom prst="rect">
             <a:avLst/>
@@ -3837,44 +3769,49 @@
           <a:p>
             <a:pPr>
               <a:lnSpc>
-                <a:spcPct val="120000"/>
+                <a:spcPct val="115000"/>
               </a:lnSpc>
             </a:pPr>
             <a:r>
-              <a:rPr sz="1150">
-                <a:solidFill>
-                  <a:srgbClr val="F5F3EC"/>
+              <a:rPr sz="1450" b="1">
+                <a:solidFill>
+                  <a:srgbClr val="FFB454"/>
                 </a:solidFill>
                 <a:latin typeface="Arial"/>
               </a:rPr>
-              <a:t>当贝發表 X9 Max（支援 4800 CVIA 亮度、QuaLas42 激光器與 MT9681 晶片）；soundcore Nebula 推出 X1S 智慧投影機（4K 解析度、6000 流明 RGB 雷射光源）；堅果推出業界首款 360 度全景智能投影儀 MIGO；騰訊則上架極光投影儀 F5（IT之家、ProjectorReviews）。</a:t>
-            </a:r>
-          </a:p>
-        </p:txBody>
-      </p:sp>
-      <p:sp>
-        <p:nvSpPr>
-          <p:cNvPr id="10" name="Rounded Rectangle 9"/>
+              <a:t>高階智慧與雷射新品亮相</a:t>
+            </a:r>
+            <a:r>
+              <a:rPr sz="1450">
+                <a:solidFill>
+                  <a:srgbClr val="F5F3EC"/>
+                </a:solidFill>
+                <a:latin typeface="Arial"/>
+              </a:rPr>
+              <a:t>：</a:t>
+            </a:r>
+          </a:p>
+        </p:txBody>
+      </p:sp>
+      <p:sp>
+        <p:nvSpPr>
+          <p:cNvPr id="8" name="Oval 7"/>
           <p:cNvSpPr/>
           <p:nvPr/>
         </p:nvSpPr>
         <p:spPr>
           <a:xfrm>
-            <a:off x="8097316" y="1600200"/>
-            <a:ext cx="3545738" cy="4754880"/>
-          </a:xfrm>
-          <a:prstGeom prst="roundRect">
-            <a:avLst>
-              <a:gd name="adj" fmla="val 6000"/>
-            </a:avLst>
+            <a:off x="594360" y="2770632"/>
+            <a:ext cx="100584" cy="100584"/>
+          </a:xfrm>
+          <a:prstGeom prst="ellipse">
+            <a:avLst/>
           </a:prstGeom>
           <a:solidFill>
-            <a:srgbClr val="23262F"/>
+            <a:srgbClr val="4C7EFF"/>
           </a:solidFill>
-          <a:ln w="12700">
-            <a:solidFill>
-              <a:srgbClr val="8B7FD6"/>
-            </a:solidFill>
+          <a:ln>
+            <a:noFill/>
           </a:ln>
           <a:effectLst/>
         </p:spPr>
@@ -3902,49 +3839,97 @@
       </p:sp>
       <p:sp>
         <p:nvSpPr>
+          <p:cNvPr id="9" name="TextBox 8"/>
+          <p:cNvSpPr txBox="1"/>
+          <p:nvPr/>
+        </p:nvSpPr>
+        <p:spPr>
+          <a:xfrm>
+            <a:off x="868680" y="2642616"/>
+            <a:ext cx="10698480" cy="640080"/>
+          </a:xfrm>
+          <a:prstGeom prst="rect">
+            <a:avLst/>
+          </a:prstGeom>
+          <a:noFill/>
+        </p:spPr>
+        <p:txBody>
+          <a:bodyPr wrap="square">
+            <a:spAutoFit/>
+          </a:bodyPr>
+          <a:lstStyle/>
+          <a:p>
+            <a:pPr>
+              <a:lnSpc>
+                <a:spcPct val="115000"/>
+              </a:lnSpc>
+            </a:pPr>
+            <a:r>
+              <a:rPr sz="1450">
+                <a:solidFill>
+                  <a:srgbClr val="F5F3EC"/>
+                </a:solidFill>
+                <a:latin typeface="Arial"/>
+              </a:rPr>
+              <a:t>当贝發布 X9 Max 投影儀，主打 4800 CVIA 亮度、80000:1 動態對比度、QuaLas42 激光器與 MT9681 晶片（IT之家）。</a:t>
+            </a:r>
+          </a:p>
+        </p:txBody>
+      </p:sp>
+      <p:sp>
+        <p:nvSpPr>
+          <p:cNvPr id="10" name="Oval 9"/>
+          <p:cNvSpPr/>
+          <p:nvPr/>
+        </p:nvSpPr>
+        <p:spPr>
+          <a:xfrm>
+            <a:off x="594360" y="3410712"/>
+            <a:ext cx="100584" cy="100584"/>
+          </a:xfrm>
+          <a:prstGeom prst="ellipse">
+            <a:avLst/>
+          </a:prstGeom>
+          <a:solidFill>
+            <a:srgbClr val="4C7EFF"/>
+          </a:solidFill>
+          <a:ln>
+            <a:noFill/>
+          </a:ln>
+          <a:effectLst/>
+        </p:spPr>
+        <p:style>
+          <a:lnRef idx="1">
+            <a:schemeClr val="accent1"/>
+          </a:lnRef>
+          <a:fillRef idx="3">
+            <a:schemeClr val="accent1"/>
+          </a:fillRef>
+          <a:effectRef idx="2">
+            <a:schemeClr val="accent1"/>
+          </a:effectRef>
+          <a:fontRef idx="minor">
+            <a:schemeClr val="lt1"/>
+          </a:fontRef>
+        </p:style>
+        <p:txBody>
+          <a:bodyPr rtlCol="0" anchor="ctr"/>
+          <a:lstStyle/>
+          <a:p>
+            <a:pPr algn="ctr"/>
+          </a:p>
+        </p:txBody>
+      </p:sp>
+      <p:sp>
+        <p:nvSpPr>
           <p:cNvPr id="11" name="TextBox 10"/>
           <p:cNvSpPr txBox="1"/>
           <p:nvPr/>
         </p:nvSpPr>
         <p:spPr>
           <a:xfrm>
-            <a:off x="8298484" y="1764792"/>
-            <a:ext cx="3143402" cy="457200"/>
-          </a:xfrm>
-          <a:prstGeom prst="rect">
-            <a:avLst/>
-          </a:prstGeom>
-          <a:noFill/>
-        </p:spPr>
-        <p:txBody>
-          <a:bodyPr wrap="square" anchor="t">
-            <a:spAutoFit/>
-          </a:bodyPr>
-          <a:lstStyle/>
-          <a:p>
-            <a:pPr algn="l"/>
-            <a:r>
-              <a:rPr sz="1450" b="1">
-                <a:solidFill>
-                  <a:srgbClr val="8B7FD6"/>
-                </a:solidFill>
-                <a:latin typeface="Arial"/>
-              </a:rPr>
-              <a:t>展會與空間升級</a:t>
-            </a:r>
-          </a:p>
-        </p:txBody>
-      </p:sp>
-      <p:sp>
-        <p:nvSpPr>
-          <p:cNvPr id="12" name="TextBox 11"/>
-          <p:cNvSpPr txBox="1"/>
-          <p:nvPr/>
-        </p:nvSpPr>
-        <p:spPr>
-          <a:xfrm>
-            <a:off x="8298484" y="2258568"/>
-            <a:ext cx="3143402" cy="3931920"/>
+            <a:off x="868680" y="3282696"/>
+            <a:ext cx="10698480" cy="640080"/>
           </a:xfrm>
           <a:prstGeom prst="rect">
             <a:avLst/>
@@ -3959,24 +3944,365 @@
           <a:p>
             <a:pPr>
               <a:lnSpc>
-                <a:spcPct val="120000"/>
+                <a:spcPct val="115000"/>
               </a:lnSpc>
             </a:pPr>
             <a:r>
-              <a:rPr sz="1150">
+              <a:rPr sz="1450">
                 <a:solidFill>
                   <a:srgbClr val="F5F3EC"/>
                 </a:solidFill>
                 <a:latin typeface="Arial"/>
               </a:rPr>
-              <a:t>CEDIA Expo 2026 展出前沿投影產品與投影幕技術；科視 Christie 上海演示室完成全面升級，展出 Eclipse G3 等高階純雷射投影系統；印度詞語博物館則採用 16 台科視雷射投影機打造互動體驗（ProjectorCentral、投影時代）。</a:t>
-            </a:r>
+              <a:t>soundcore Nebula 推出 X1S 智慧投影機，搭載 4K 解析度與 6000 流明 RGB 雷射光源，建議售價 2499 美元起（ProjectorReviews）。</a:t>
+            </a:r>
+          </a:p>
+        </p:txBody>
+      </p:sp>
+      <p:sp>
+        <p:nvSpPr>
+          <p:cNvPr id="12" name="Oval 11"/>
+          <p:cNvSpPr/>
+          <p:nvPr/>
+        </p:nvSpPr>
+        <p:spPr>
+          <a:xfrm>
+            <a:off x="594360" y="4050792"/>
+            <a:ext cx="100584" cy="100584"/>
+          </a:xfrm>
+          <a:prstGeom prst="ellipse">
+            <a:avLst/>
+          </a:prstGeom>
+          <a:solidFill>
+            <a:srgbClr val="4C7EFF"/>
+          </a:solidFill>
+          <a:ln>
+            <a:noFill/>
+          </a:ln>
+          <a:effectLst/>
+        </p:spPr>
+        <p:style>
+          <a:lnRef idx="1">
+            <a:schemeClr val="accent1"/>
+          </a:lnRef>
+          <a:fillRef idx="3">
+            <a:schemeClr val="accent1"/>
+          </a:fillRef>
+          <a:effectRef idx="2">
+            <a:schemeClr val="accent1"/>
+          </a:effectRef>
+          <a:fontRef idx="minor">
+            <a:schemeClr val="lt1"/>
+          </a:fontRef>
+        </p:style>
+        <p:txBody>
+          <a:bodyPr rtlCol="0" anchor="ctr"/>
+          <a:lstStyle/>
+          <a:p>
+            <a:pPr algn="ctr"/>
           </a:p>
         </p:txBody>
       </p:sp>
       <p:sp>
         <p:nvSpPr>
           <p:cNvPr id="13" name="TextBox 12"/>
+          <p:cNvSpPr txBox="1"/>
+          <p:nvPr/>
+        </p:nvSpPr>
+        <p:spPr>
+          <a:xfrm>
+            <a:off x="868680" y="3922776"/>
+            <a:ext cx="10698480" cy="640080"/>
+          </a:xfrm>
+          <a:prstGeom prst="rect">
+            <a:avLst/>
+          </a:prstGeom>
+          <a:noFill/>
+        </p:spPr>
+        <p:txBody>
+          <a:bodyPr wrap="square">
+            <a:spAutoFit/>
+          </a:bodyPr>
+          <a:lstStyle/>
+          <a:p>
+            <a:pPr>
+              <a:lnSpc>
+                <a:spcPct val="115000"/>
+              </a:lnSpc>
+            </a:pPr>
+            <a:r>
+              <a:rPr sz="1450">
+                <a:solidFill>
+                  <a:srgbClr val="F5F3EC"/>
+                </a:solidFill>
+                <a:latin typeface="Arial"/>
+              </a:rPr>
+              <a:t>堅果發布首款 360 度全景智能投影儀 MIGO，具備 750 CVIA 亮度與 DLP 顯示技術，國補到手價 1599.3 元（IT之家）。</a:t>
+            </a:r>
+          </a:p>
+        </p:txBody>
+      </p:sp>
+      <p:sp>
+        <p:nvSpPr>
+          <p:cNvPr id="14" name="Oval 13"/>
+          <p:cNvSpPr/>
+          <p:nvPr/>
+        </p:nvSpPr>
+        <p:spPr>
+          <a:xfrm>
+            <a:off x="594360" y="4690872"/>
+            <a:ext cx="100584" cy="100584"/>
+          </a:xfrm>
+          <a:prstGeom prst="ellipse">
+            <a:avLst/>
+          </a:prstGeom>
+          <a:solidFill>
+            <a:srgbClr val="4C7EFF"/>
+          </a:solidFill>
+          <a:ln>
+            <a:noFill/>
+          </a:ln>
+          <a:effectLst/>
+        </p:spPr>
+        <p:style>
+          <a:lnRef idx="1">
+            <a:schemeClr val="accent1"/>
+          </a:lnRef>
+          <a:fillRef idx="3">
+            <a:schemeClr val="accent1"/>
+          </a:fillRef>
+          <a:effectRef idx="2">
+            <a:schemeClr val="accent1"/>
+          </a:effectRef>
+          <a:fontRef idx="minor">
+            <a:schemeClr val="lt1"/>
+          </a:fontRef>
+        </p:style>
+        <p:txBody>
+          <a:bodyPr rtlCol="0" anchor="ctr"/>
+          <a:lstStyle/>
+          <a:p>
+            <a:pPr algn="ctr"/>
+          </a:p>
+        </p:txBody>
+      </p:sp>
+      <p:sp>
+        <p:nvSpPr>
+          <p:cNvPr id="15" name="TextBox 14"/>
+          <p:cNvSpPr txBox="1"/>
+          <p:nvPr/>
+        </p:nvSpPr>
+        <p:spPr>
+          <a:xfrm>
+            <a:off x="868680" y="4562856"/>
+            <a:ext cx="10698480" cy="640080"/>
+          </a:xfrm>
+          <a:prstGeom prst="rect">
+            <a:avLst/>
+          </a:prstGeom>
+          <a:noFill/>
+        </p:spPr>
+        <p:txBody>
+          <a:bodyPr wrap="square">
+            <a:spAutoFit/>
+          </a:bodyPr>
+          <a:lstStyle/>
+          <a:p>
+            <a:pPr>
+              <a:lnSpc>
+                <a:spcPct val="115000"/>
+              </a:lnSpc>
+            </a:pPr>
+            <a:r>
+              <a:rPr sz="1450">
+                <a:solidFill>
+                  <a:srgbClr val="F5F3EC"/>
+                </a:solidFill>
+                <a:latin typeface="Arial"/>
+              </a:rPr>
+              <a:t>騰訊上架極光投影儀 F5，主打 1080P 解析度與 345CVIA 流明，售價 822 元人民幣起（IT之家）。</a:t>
+            </a:r>
+          </a:p>
+        </p:txBody>
+      </p:sp>
+      <p:sp>
+        <p:nvSpPr>
+          <p:cNvPr id="16" name="Oval 15"/>
+          <p:cNvSpPr/>
+          <p:nvPr/>
+        </p:nvSpPr>
+        <p:spPr>
+          <a:xfrm>
+            <a:off x="594360" y="5330952"/>
+            <a:ext cx="100584" cy="100584"/>
+          </a:xfrm>
+          <a:prstGeom prst="ellipse">
+            <a:avLst/>
+          </a:prstGeom>
+          <a:solidFill>
+            <a:srgbClr val="4C7EFF"/>
+          </a:solidFill>
+          <a:ln>
+            <a:noFill/>
+          </a:ln>
+          <a:effectLst/>
+        </p:spPr>
+        <p:style>
+          <a:lnRef idx="1">
+            <a:schemeClr val="accent1"/>
+          </a:lnRef>
+          <a:fillRef idx="3">
+            <a:schemeClr val="accent1"/>
+          </a:fillRef>
+          <a:effectRef idx="2">
+            <a:schemeClr val="accent1"/>
+          </a:effectRef>
+          <a:fontRef idx="minor">
+            <a:schemeClr val="lt1"/>
+          </a:fontRef>
+        </p:style>
+        <p:txBody>
+          <a:bodyPr rtlCol="0" anchor="ctr"/>
+          <a:lstStyle/>
+          <a:p>
+            <a:pPr algn="ctr"/>
+          </a:p>
+        </p:txBody>
+      </p:sp>
+      <p:sp>
+        <p:nvSpPr>
+          <p:cNvPr id="17" name="TextBox 16"/>
+          <p:cNvSpPr txBox="1"/>
+          <p:nvPr/>
+        </p:nvSpPr>
+        <p:spPr>
+          <a:xfrm>
+            <a:off x="868680" y="5202936"/>
+            <a:ext cx="10698480" cy="402336"/>
+          </a:xfrm>
+          <a:prstGeom prst="rect">
+            <a:avLst/>
+          </a:prstGeom>
+          <a:noFill/>
+        </p:spPr>
+        <p:txBody>
+          <a:bodyPr wrap="square">
+            <a:spAutoFit/>
+          </a:bodyPr>
+          <a:lstStyle/>
+          <a:p>
+            <a:pPr>
+              <a:lnSpc>
+                <a:spcPct val="115000"/>
+              </a:lnSpc>
+            </a:pPr>
+            <a:r>
+              <a:rPr sz="1450" b="1">
+                <a:solidFill>
+                  <a:srgbClr val="FFB454"/>
+                </a:solidFill>
+                <a:latin typeface="Arial"/>
+              </a:rPr>
+              <a:t>展館與專業空間升級</a:t>
+            </a:r>
+            <a:r>
+              <a:rPr sz="1450">
+                <a:solidFill>
+                  <a:srgbClr val="F5F3EC"/>
+                </a:solidFill>
+                <a:latin typeface="Arial"/>
+              </a:rPr>
+              <a:t>：</a:t>
+            </a:r>
+          </a:p>
+        </p:txBody>
+      </p:sp>
+      <p:sp>
+        <p:nvSpPr>
+          <p:cNvPr id="18" name="Oval 17"/>
+          <p:cNvSpPr/>
+          <p:nvPr/>
+        </p:nvSpPr>
+        <p:spPr>
+          <a:xfrm>
+            <a:off x="594360" y="5733288"/>
+            <a:ext cx="100584" cy="100584"/>
+          </a:xfrm>
+          <a:prstGeom prst="ellipse">
+            <a:avLst/>
+          </a:prstGeom>
+          <a:solidFill>
+            <a:srgbClr val="4C7EFF"/>
+          </a:solidFill>
+          <a:ln>
+            <a:noFill/>
+          </a:ln>
+          <a:effectLst/>
+        </p:spPr>
+        <p:style>
+          <a:lnRef idx="1">
+            <a:schemeClr val="accent1"/>
+          </a:lnRef>
+          <a:fillRef idx="3">
+            <a:schemeClr val="accent1"/>
+          </a:fillRef>
+          <a:effectRef idx="2">
+            <a:schemeClr val="accent1"/>
+          </a:effectRef>
+          <a:fontRef idx="minor">
+            <a:schemeClr val="lt1"/>
+          </a:fontRef>
+        </p:style>
+        <p:txBody>
+          <a:bodyPr rtlCol="0" anchor="ctr"/>
+          <a:lstStyle/>
+          <a:p>
+            <a:pPr algn="ctr"/>
+          </a:p>
+        </p:txBody>
+      </p:sp>
+      <p:sp>
+        <p:nvSpPr>
+          <p:cNvPr id="19" name="TextBox 18"/>
+          <p:cNvSpPr txBox="1"/>
+          <p:nvPr/>
+        </p:nvSpPr>
+        <p:spPr>
+          <a:xfrm>
+            <a:off x="868680" y="5605272"/>
+            <a:ext cx="10698480" cy="640080"/>
+          </a:xfrm>
+          <a:prstGeom prst="rect">
+            <a:avLst/>
+          </a:prstGeom>
+          <a:noFill/>
+        </p:spPr>
+        <p:txBody>
+          <a:bodyPr wrap="square">
+            <a:spAutoFit/>
+          </a:bodyPr>
+          <a:lstStyle/>
+          <a:p>
+            <a:pPr>
+              <a:lnSpc>
+                <a:spcPct val="115000"/>
+              </a:lnSpc>
+            </a:pPr>
+            <a:r>
+              <a:rPr sz="1450">
+                <a:solidFill>
+                  <a:srgbClr val="F5F3EC"/>
+                </a:solidFill>
+                <a:latin typeface="Arial"/>
+              </a:rPr>
+              <a:t>科視 Christie 上海辦公室 3000 平米演示室完成升級，展出 Eclipse G3、Griffyn 與 M4K 系列等高階純雷射投影機（投影時代、投影時代）。</a:t>
+            </a:r>
+          </a:p>
+        </p:txBody>
+      </p:sp>
+      <p:sp>
+        <p:nvSpPr>
+          <p:cNvPr id="20" name="TextBox 19"/>
           <p:cNvSpPr txBox="1"/>
           <p:nvPr/>
         </p:nvSpPr>
@@ -4065,7 +4391,7 @@
                 </a:solidFill>
                 <a:latin typeface="Arial"/>
               </a:rPr>
-              <a:t>04 · SECTION　🔧</a:t>
+              <a:t>04 · SECTION　✨</a:t>
             </a:r>
           </a:p>
         </p:txBody>
@@ -4100,34 +4426,30 @@
                 </a:solidFill>
                 <a:latin typeface="Arial"/>
               </a:rPr>
-              <a:t>技術與供應鏈</a:t>
-            </a:r>
-          </a:p>
-        </p:txBody>
-      </p:sp>
-      <p:sp>
-        <p:nvSpPr>
-          <p:cNvPr id="4" name="Rounded Rectangle 3"/>
+              <a:t>市場與品牌動態</a:t>
+            </a:r>
+          </a:p>
+        </p:txBody>
+      </p:sp>
+      <p:sp>
+        <p:nvSpPr>
+          <p:cNvPr id="4" name="Oval 3"/>
           <p:cNvSpPr/>
           <p:nvPr/>
         </p:nvSpPr>
         <p:spPr>
           <a:xfrm>
-            <a:off x="548640" y="1600200"/>
-            <a:ext cx="11094415" cy="4754880"/>
-          </a:xfrm>
-          <a:prstGeom prst="roundRect">
-            <a:avLst>
-              <a:gd name="adj" fmla="val 6000"/>
-            </a:avLst>
+            <a:off x="594360" y="1728216"/>
+            <a:ext cx="100584" cy="100584"/>
+          </a:xfrm>
+          <a:prstGeom prst="ellipse">
+            <a:avLst/>
           </a:prstGeom>
           <a:solidFill>
-            <a:srgbClr val="23262F"/>
+            <a:srgbClr val="4C7EFF"/>
           </a:solidFill>
-          <a:ln w="12700">
-            <a:solidFill>
-              <a:srgbClr val="4C7EFF"/>
-            </a:solidFill>
+          <a:ln>
+            <a:noFill/>
           </a:ln>
           <a:effectLst/>
         </p:spPr>
@@ -4161,43 +4483,8 @@
         </p:nvSpPr>
         <p:spPr>
           <a:xfrm>
-            <a:off x="749808" y="1764792"/>
-            <a:ext cx="10692079" cy="457200"/>
-          </a:xfrm>
-          <a:prstGeom prst="rect">
-            <a:avLst/>
-          </a:prstGeom>
-          <a:noFill/>
-        </p:spPr>
-        <p:txBody>
-          <a:bodyPr wrap="square" anchor="t">
-            <a:spAutoFit/>
-          </a:bodyPr>
-          <a:lstStyle/>
-          <a:p>
-            <a:pPr algn="l"/>
-            <a:r>
-              <a:rPr sz="1450" b="1">
-                <a:solidFill>
-                  <a:srgbClr val="4C7EFF"/>
-                </a:solidFill>
-                <a:latin typeface="Arial"/>
-              </a:rPr>
-              <a:t>矽光子與光學互連</a:t>
-            </a:r>
-          </a:p>
-        </p:txBody>
-      </p:sp>
-      <p:sp>
-        <p:nvSpPr>
-          <p:cNvPr id="6" name="TextBox 5"/>
-          <p:cNvSpPr txBox="1"/>
-          <p:nvPr/>
-        </p:nvSpPr>
-        <p:spPr>
-          <a:xfrm>
-            <a:off x="749808" y="2258568"/>
-            <a:ext cx="10692079" cy="3931920"/>
+            <a:off x="868680" y="1600200"/>
+            <a:ext cx="10698480" cy="640080"/>
           </a:xfrm>
           <a:prstGeom prst="rect">
             <a:avLst/>
@@ -4212,24 +4499,107 @@
           <a:p>
             <a:pPr>
               <a:lnSpc>
-                <a:spcPct val="120000"/>
+                <a:spcPct val="115000"/>
               </a:lnSpc>
             </a:pPr>
             <a:r>
-              <a:rPr sz="1150">
+              <a:rPr sz="1450">
                 <a:solidFill>
                   <a:srgbClr val="F5F3EC"/>
                 </a:solidFill>
                 <a:latin typeface="Arial"/>
               </a:rPr>
-              <a:t>矽光子技術發展下，光學模組的生產瓶頸已從下游元件製造端向上游雷射級基板供應轉移。同時，隨著 AI 競賽重心轉向資料傳輸與連接技術，鴻騰精密正積極擴大光學互連產品的研發與佈局（DigiTimes）。</a:t>
-            </a:r>
+              <a:t>印度加爾各答詞語博物館採用 16 台科視雷射投影機（包含 Captiva 超短焦與 Inspire 系列 1DLP 機型）打造互動視覺體驗（投影時代）。</a:t>
+            </a:r>
+          </a:p>
+        </p:txBody>
+      </p:sp>
+      <p:sp>
+        <p:nvSpPr>
+          <p:cNvPr id="6" name="Oval 5"/>
+          <p:cNvSpPr/>
+          <p:nvPr/>
+        </p:nvSpPr>
+        <p:spPr>
+          <a:xfrm>
+            <a:off x="594360" y="2368296"/>
+            <a:ext cx="100584" cy="100584"/>
+          </a:xfrm>
+          <a:prstGeom prst="ellipse">
+            <a:avLst/>
+          </a:prstGeom>
+          <a:solidFill>
+            <a:srgbClr val="4C7EFF"/>
+          </a:solidFill>
+          <a:ln>
+            <a:noFill/>
+          </a:ln>
+          <a:effectLst/>
+        </p:spPr>
+        <p:style>
+          <a:lnRef idx="1">
+            <a:schemeClr val="accent1"/>
+          </a:lnRef>
+          <a:fillRef idx="3">
+            <a:schemeClr val="accent1"/>
+          </a:fillRef>
+          <a:effectRef idx="2">
+            <a:schemeClr val="accent1"/>
+          </a:effectRef>
+          <a:fontRef idx="minor">
+            <a:schemeClr val="lt1"/>
+          </a:fontRef>
+        </p:style>
+        <p:txBody>
+          <a:bodyPr rtlCol="0" anchor="ctr"/>
+          <a:lstStyle/>
+          <a:p>
+            <a:pPr algn="ctr"/>
           </a:p>
         </p:txBody>
       </p:sp>
       <p:sp>
         <p:nvSpPr>
           <p:cNvPr id="7" name="TextBox 6"/>
+          <p:cNvSpPr txBox="1"/>
+          <p:nvPr/>
+        </p:nvSpPr>
+        <p:spPr>
+          <a:xfrm>
+            <a:off x="868680" y="2240280"/>
+            <a:ext cx="10698480" cy="640080"/>
+          </a:xfrm>
+          <a:prstGeom prst="rect">
+            <a:avLst/>
+          </a:prstGeom>
+          <a:noFill/>
+        </p:spPr>
+        <p:txBody>
+          <a:bodyPr wrap="square">
+            <a:spAutoFit/>
+          </a:bodyPr>
+          <a:lstStyle/>
+          <a:p>
+            <a:pPr>
+              <a:lnSpc>
+                <a:spcPct val="115000"/>
+              </a:lnSpc>
+            </a:pPr>
+            <a:r>
+              <a:rPr sz="1450">
+                <a:solidFill>
+                  <a:srgbClr val="F5F3EC"/>
+                </a:solidFill>
+                <a:latin typeface="Arial"/>
+              </a:rPr>
+              <a:t>波士頓歌劇院攜手 MASARY工作室，採用 Epson 大型場館 4K 雷射投影機將字幕轉化為動態舞台藝術（Epson官方）。</a:t>
+            </a:r>
+          </a:p>
+        </p:txBody>
+      </p:sp>
+      <p:sp>
+        <p:nvSpPr>
+          <p:cNvPr id="8" name="TextBox 7"/>
           <p:cNvSpPr txBox="1"/>
           <p:nvPr/>
         </p:nvSpPr>
@@ -4318,7 +4688,7 @@
                 </a:solidFill>
                 <a:latin typeface="Arial"/>
               </a:rPr>
-              <a:t>05 · SECTION　🔭</a:t>
+              <a:t>05 · SECTION　🔧</a:t>
             </a:r>
           </a:p>
         </p:txBody>
@@ -4353,30 +4723,34 @@
                 </a:solidFill>
                 <a:latin typeface="Arial"/>
               </a:rPr>
-              <a:t>下週關注</a:t>
-            </a:r>
-          </a:p>
-        </p:txBody>
-      </p:sp>
-      <p:sp>
-        <p:nvSpPr>
-          <p:cNvPr id="4" name="Oval 3"/>
+              <a:t>技術與供應鏈</a:t>
+            </a:r>
+          </a:p>
+        </p:txBody>
+      </p:sp>
+      <p:sp>
+        <p:nvSpPr>
+          <p:cNvPr id="4" name="Rounded Rectangle 3"/>
           <p:cNvSpPr/>
           <p:nvPr/>
         </p:nvSpPr>
         <p:spPr>
           <a:xfrm>
-            <a:off x="594360" y="1728216"/>
-            <a:ext cx="100584" cy="100584"/>
-          </a:xfrm>
-          <a:prstGeom prst="ellipse">
-            <a:avLst/>
+            <a:off x="548640" y="1600200"/>
+            <a:ext cx="5432907" cy="4754880"/>
+          </a:xfrm>
+          <a:prstGeom prst="roundRect">
+            <a:avLst>
+              <a:gd name="adj" fmla="val 6000"/>
+            </a:avLst>
           </a:prstGeom>
           <a:solidFill>
-            <a:srgbClr val="4C7EFF"/>
+            <a:srgbClr val="23262F"/>
           </a:solidFill>
-          <a:ln>
-            <a:noFill/>
+          <a:ln w="12700">
+            <a:solidFill>
+              <a:srgbClr val="4C7EFF"/>
+            </a:solidFill>
           </a:ln>
           <a:effectLst/>
         </p:spPr>
@@ -4410,8 +4784,43 @@
         </p:nvSpPr>
         <p:spPr>
           <a:xfrm>
-            <a:off x="868680" y="1600200"/>
-            <a:ext cx="10698480" cy="402336"/>
+            <a:off x="749808" y="1764792"/>
+            <a:ext cx="5030571" cy="457200"/>
+          </a:xfrm>
+          <a:prstGeom prst="rect">
+            <a:avLst/>
+          </a:prstGeom>
+          <a:noFill/>
+        </p:spPr>
+        <p:txBody>
+          <a:bodyPr wrap="square" anchor="t">
+            <a:spAutoFit/>
+          </a:bodyPr>
+          <a:lstStyle/>
+          <a:p>
+            <a:pPr algn="l"/>
+            <a:r>
+              <a:rPr sz="1450" b="1">
+                <a:solidFill>
+                  <a:srgbClr val="4C7EFF"/>
+                </a:solidFill>
+                <a:latin typeface="Arial"/>
+              </a:rPr>
+              <a:t>矽光子與光學模組瓶頸轉移</a:t>
+            </a:r>
+          </a:p>
+        </p:txBody>
+      </p:sp>
+      <p:sp>
+        <p:nvSpPr>
+          <p:cNvPr id="6" name="TextBox 5"/>
+          <p:cNvSpPr txBox="1"/>
+          <p:nvPr/>
+        </p:nvSpPr>
+        <p:spPr>
+          <a:xfrm>
+            <a:off x="749808" y="2258568"/>
+            <a:ext cx="5030571" cy="3931920"/>
           </a:xfrm>
           <a:prstGeom prst="rect">
             <a:avLst/>
@@ -4426,40 +4835,44 @@
           <a:p>
             <a:pPr>
               <a:lnSpc>
-                <a:spcPct val="115000"/>
+                <a:spcPct val="120000"/>
               </a:lnSpc>
             </a:pPr>
             <a:r>
-              <a:rPr sz="1450">
+              <a:rPr sz="1150">
                 <a:solidFill>
                   <a:srgbClr val="F5F3EC"/>
                 </a:solidFill>
                 <a:latin typeface="Arial"/>
               </a:rPr>
-              <a:t>高階雷射投影機與智慧投影新品在商用展廳、會議室與家用市場的終端實際銷售與促銷反應。</a:t>
-            </a:r>
-          </a:p>
-        </p:txBody>
-      </p:sp>
-      <p:sp>
-        <p:nvSpPr>
-          <p:cNvPr id="6" name="Oval 5"/>
+              <a:t>隨著矽光子技術發展，光學模組的生產瓶頸已從下游元件製造端，向上游轉移至雷射級基板的供應，突顯上游原材料與基板技術在顯示光學應用中的關鍵地位（DigiTimes）。</a:t>
+            </a:r>
+          </a:p>
+        </p:txBody>
+      </p:sp>
+      <p:sp>
+        <p:nvSpPr>
+          <p:cNvPr id="7" name="Rounded Rectangle 6"/>
           <p:cNvSpPr/>
           <p:nvPr/>
         </p:nvSpPr>
         <p:spPr>
           <a:xfrm>
-            <a:off x="594360" y="2130552"/>
-            <a:ext cx="100584" cy="100584"/>
-          </a:xfrm>
-          <a:prstGeom prst="ellipse">
-            <a:avLst/>
+            <a:off x="6210147" y="1600200"/>
+            <a:ext cx="5432907" cy="4754880"/>
+          </a:xfrm>
+          <a:prstGeom prst="roundRect">
+            <a:avLst>
+              <a:gd name="adj" fmla="val 6000"/>
+            </a:avLst>
           </a:prstGeom>
           <a:solidFill>
-            <a:srgbClr val="4C7EFF"/>
+            <a:srgbClr val="23262F"/>
           </a:solidFill>
-          <a:ln>
-            <a:noFill/>
+          <a:ln w="12700">
+            <a:solidFill>
+              <a:srgbClr val="FFB454"/>
+            </a:solidFill>
           </a:ln>
           <a:effectLst/>
         </p:spPr>
@@ -4487,14 +4900,49 @@
       </p:sp>
       <p:sp>
         <p:nvSpPr>
-          <p:cNvPr id="7" name="TextBox 6"/>
+          <p:cNvPr id="8" name="TextBox 7"/>
           <p:cNvSpPr txBox="1"/>
           <p:nvPr/>
         </p:nvSpPr>
         <p:spPr>
           <a:xfrm>
-            <a:off x="868680" y="2002536"/>
-            <a:ext cx="10698480" cy="402336"/>
+            <a:off x="6411315" y="1764792"/>
+            <a:ext cx="5030571" cy="457200"/>
+          </a:xfrm>
+          <a:prstGeom prst="rect">
+            <a:avLst/>
+          </a:prstGeom>
+          <a:noFill/>
+        </p:spPr>
+        <p:txBody>
+          <a:bodyPr wrap="square" anchor="t">
+            <a:spAutoFit/>
+          </a:bodyPr>
+          <a:lstStyle/>
+          <a:p>
+            <a:pPr algn="l"/>
+            <a:r>
+              <a:rPr sz="1450" b="1">
+                <a:solidFill>
+                  <a:srgbClr val="FFB454"/>
+                </a:solidFill>
+                <a:latin typeface="Arial"/>
+              </a:rPr>
+              <a:t>AI 競賽驅動連接技術</a:t>
+            </a:r>
+          </a:p>
+        </p:txBody>
+      </p:sp>
+      <p:sp>
+        <p:nvSpPr>
+          <p:cNvPr id="9" name="TextBox 8"/>
+          <p:cNvSpPr txBox="1"/>
+          <p:nvPr/>
+        </p:nvSpPr>
+        <p:spPr>
+          <a:xfrm>
+            <a:off x="6411315" y="2258568"/>
+            <a:ext cx="5030571" cy="3931920"/>
           </a:xfrm>
           <a:prstGeom prst="rect">
             <a:avLst/>
@@ -4509,24 +4957,24 @@
           <a:p>
             <a:pPr>
               <a:lnSpc>
-                <a:spcPct val="115000"/>
+                <a:spcPct val="120000"/>
               </a:lnSpc>
             </a:pPr>
             <a:r>
-              <a:rPr sz="1450">
+              <a:rPr sz="1150">
                 <a:solidFill>
                   <a:srgbClr val="F5F3EC"/>
                 </a:solidFill>
                 <a:latin typeface="Arial"/>
               </a:rPr>
-              <a:t>上游矽光子雷射級基板供應鏈的後續發展對光學模組與顯示設備帶動的影響。</a:t>
-            </a:r>
-          </a:p>
-        </p:txBody>
-      </p:sp>
-      <p:sp>
-        <p:nvSpPr>
-          <p:cNvPr id="8" name="TextBox 7"/>
+              <a:t>隨著 AI 競賽重心轉向資料傳輸與連接技術，鴻騰精密（FIT）正積極擴大光學互連產品的研發與佈局，提升高速傳輸效能與高頻寬資料中心互連技術（DigiTimes）。</a:t>
+            </a:r>
+          </a:p>
+        </p:txBody>
+      </p:sp>
+      <p:sp>
+        <p:nvSpPr>
+          <p:cNvPr id="10" name="TextBox 9"/>
           <p:cNvSpPr txBox="1"/>
           <p:nvPr/>
         </p:nvSpPr>
@@ -4587,22 +5035,90 @@
       <p:grpSpPr/>
       <p:sp>
         <p:nvSpPr>
-          <p:cNvPr id="2" name="Oval 1"/>
+          <p:cNvPr id="2" name="TextBox 1"/>
+          <p:cNvSpPr txBox="1"/>
+          <p:nvPr/>
+        </p:nvSpPr>
+        <p:spPr>
+          <a:xfrm>
+            <a:off x="548640" y="384048"/>
+            <a:ext cx="7315200" cy="320040"/>
+          </a:xfrm>
+          <a:prstGeom prst="rect">
+            <a:avLst/>
+          </a:prstGeom>
+          <a:noFill/>
+        </p:spPr>
+        <p:txBody>
+          <a:bodyPr wrap="square" anchor="t">
+            <a:spAutoFit/>
+          </a:bodyPr>
+          <a:lstStyle/>
+          <a:p>
+            <a:pPr algn="l"/>
+            <a:r>
+              <a:rPr sz="1100" b="1">
+                <a:solidFill>
+                  <a:srgbClr val="FFB454"/>
+                </a:solidFill>
+                <a:latin typeface="Arial"/>
+              </a:rPr>
+              <a:t>06 · SECTION　🔭</a:t>
+            </a:r>
+          </a:p>
+        </p:txBody>
+      </p:sp>
+      <p:sp>
+        <p:nvSpPr>
+          <p:cNvPr id="3" name="TextBox 2"/>
+          <p:cNvSpPr txBox="1"/>
+          <p:nvPr/>
+        </p:nvSpPr>
+        <p:spPr>
+          <a:xfrm>
+            <a:off x="548640" y="713232"/>
+            <a:ext cx="10972800" cy="685800"/>
+          </a:xfrm>
+          <a:prstGeom prst="rect">
+            <a:avLst/>
+          </a:prstGeom>
+          <a:noFill/>
+        </p:spPr>
+        <p:txBody>
+          <a:bodyPr wrap="square" anchor="t">
+            <a:spAutoFit/>
+          </a:bodyPr>
+          <a:lstStyle/>
+          <a:p>
+            <a:pPr algn="l"/>
+            <a:r>
+              <a:rPr sz="2600" b="1">
+                <a:solidFill>
+                  <a:srgbClr val="F5F3EC"/>
+                </a:solidFill>
+                <a:latin typeface="Arial"/>
+              </a:rPr>
+              <a:t>下週關注</a:t>
+            </a:r>
+          </a:p>
+        </p:txBody>
+      </p:sp>
+      <p:sp>
+        <p:nvSpPr>
+          <p:cNvPr id="4" name="Oval 3"/>
           <p:cNvSpPr/>
           <p:nvPr/>
         </p:nvSpPr>
         <p:spPr>
           <a:xfrm>
-            <a:off x="8961120" y="3200400"/>
-            <a:ext cx="5486400" cy="5486400"/>
+            <a:off x="594360" y="1728216"/>
+            <a:ext cx="100584" cy="100584"/>
           </a:xfrm>
           <a:prstGeom prst="ellipse">
             <a:avLst/>
           </a:prstGeom>
           <a:solidFill>
-            <a:srgbClr val="4C7EFF">
-              <a:alpha val="10000"/>
-            </a:srgbClr>
+            <a:srgbClr val="4C7EFF"/>
           </a:solidFill>
           <a:ln>
             <a:noFill/>
@@ -4633,6 +5149,235 @@
       </p:sp>
       <p:sp>
         <p:nvSpPr>
+          <p:cNvPr id="5" name="TextBox 4"/>
+          <p:cNvSpPr txBox="1"/>
+          <p:nvPr/>
+        </p:nvSpPr>
+        <p:spPr>
+          <a:xfrm>
+            <a:off x="868680" y="1600200"/>
+            <a:ext cx="10698480" cy="640080"/>
+          </a:xfrm>
+          <a:prstGeom prst="rect">
+            <a:avLst/>
+          </a:prstGeom>
+          <a:noFill/>
+        </p:spPr>
+        <p:txBody>
+          <a:bodyPr wrap="square">
+            <a:spAutoFit/>
+          </a:bodyPr>
+          <a:lstStyle/>
+          <a:p>
+            <a:pPr>
+              <a:lnSpc>
+                <a:spcPct val="115000"/>
+              </a:lnSpc>
+            </a:pPr>
+            <a:r>
+              <a:rPr sz="1450">
+                <a:solidFill>
+                  <a:srgbClr val="F5F3EC"/>
+                </a:solidFill>
+                <a:latin typeface="Arial"/>
+              </a:rPr>
+              <a:t>智慧投影機新品（如当贝 X9 Max、堅果 MIGO 等）在市場開售後的實際銷售表現與市場迴響。</a:t>
+            </a:r>
+          </a:p>
+        </p:txBody>
+      </p:sp>
+      <p:sp>
+        <p:nvSpPr>
+          <p:cNvPr id="6" name="Oval 5"/>
+          <p:cNvSpPr/>
+          <p:nvPr/>
+        </p:nvSpPr>
+        <p:spPr>
+          <a:xfrm>
+            <a:off x="594360" y="2368296"/>
+            <a:ext cx="100584" cy="100584"/>
+          </a:xfrm>
+          <a:prstGeom prst="ellipse">
+            <a:avLst/>
+          </a:prstGeom>
+          <a:solidFill>
+            <a:srgbClr val="4C7EFF"/>
+          </a:solidFill>
+          <a:ln>
+            <a:noFill/>
+          </a:ln>
+          <a:effectLst/>
+        </p:spPr>
+        <p:style>
+          <a:lnRef idx="1">
+            <a:schemeClr val="accent1"/>
+          </a:lnRef>
+          <a:fillRef idx="3">
+            <a:schemeClr val="accent1"/>
+          </a:fillRef>
+          <a:effectRef idx="2">
+            <a:schemeClr val="accent1"/>
+          </a:effectRef>
+          <a:fontRef idx="minor">
+            <a:schemeClr val="lt1"/>
+          </a:fontRef>
+        </p:style>
+        <p:txBody>
+          <a:bodyPr rtlCol="0" anchor="ctr"/>
+          <a:lstStyle/>
+          <a:p>
+            <a:pPr algn="ctr"/>
+          </a:p>
+        </p:txBody>
+      </p:sp>
+      <p:sp>
+        <p:nvSpPr>
+          <p:cNvPr id="7" name="TextBox 6"/>
+          <p:cNvSpPr txBox="1"/>
+          <p:nvPr/>
+        </p:nvSpPr>
+        <p:spPr>
+          <a:xfrm>
+            <a:off x="868680" y="2240280"/>
+            <a:ext cx="10698480" cy="640080"/>
+          </a:xfrm>
+          <a:prstGeom prst="rect">
+            <a:avLst/>
+          </a:prstGeom>
+          <a:noFill/>
+        </p:spPr>
+        <p:txBody>
+          <a:bodyPr wrap="square">
+            <a:spAutoFit/>
+          </a:bodyPr>
+          <a:lstStyle/>
+          <a:p>
+            <a:pPr>
+              <a:lnSpc>
+                <a:spcPct val="115000"/>
+              </a:lnSpc>
+            </a:pPr>
+            <a:r>
+              <a:rPr sz="1450">
+                <a:solidFill>
+                  <a:srgbClr val="F5F3EC"/>
+                </a:solidFill>
+                <a:latin typeface="Arial"/>
+              </a:rPr>
+              <a:t>供應鏈端矽光子技術從元件製造轉向雷射級基板供應後，對上游原材料與整體顯示光學應用的進一步影響。</a:t>
+            </a:r>
+          </a:p>
+        </p:txBody>
+      </p:sp>
+      <p:sp>
+        <p:nvSpPr>
+          <p:cNvPr id="8" name="TextBox 7"/>
+          <p:cNvSpPr txBox="1"/>
+          <p:nvPr/>
+        </p:nvSpPr>
+        <p:spPr>
+          <a:xfrm>
+            <a:off x="11430000" y="6446520"/>
+            <a:ext cx="548640" cy="274320"/>
+          </a:xfrm>
+          <a:prstGeom prst="rect">
+            <a:avLst/>
+          </a:prstGeom>
+          <a:noFill/>
+        </p:spPr>
+        <p:txBody>
+          <a:bodyPr wrap="square" anchor="t">
+            <a:spAutoFit/>
+          </a:bodyPr>
+          <a:lstStyle/>
+          <a:p>
+            <a:pPr algn="r"/>
+            <a:r>
+              <a:rPr sz="1000" b="0">
+                <a:solidFill>
+                  <a:srgbClr val="9096A1"/>
+                </a:solidFill>
+                <a:latin typeface="Arial"/>
+              </a:rPr>
+              <a:t>06</a:t>
+            </a:r>
+          </a:p>
+        </p:txBody>
+      </p:sp>
+    </p:spTree>
+  </p:cSld>
+  <p:clrMapOvr>
+    <a:masterClrMapping/>
+  </p:clrMapOvr>
+</p:sld>
+</file>
+
+<file path=ppt/slides/slide7.xml><?xml version="1.0" encoding="utf-8"?>
+<p:sld xmlns:a="http://schemas.openxmlformats.org/drawingml/2006/main" xmlns:p="http://schemas.openxmlformats.org/presentationml/2006/main" xmlns:r="http://schemas.openxmlformats.org/officeDocument/2006/relationships">
+  <p:cSld>
+    <p:bg>
+      <p:bgPr>
+        <a:solidFill>
+          <a:srgbClr val="14161A"/>
+        </a:solidFill>
+        <a:effectLst/>
+      </p:bgPr>
+    </p:bg>
+    <p:spTree>
+      <p:nvGrpSpPr>
+        <p:cNvPr id="1" name=""/>
+        <p:cNvGrpSpPr/>
+        <p:nvPr/>
+      </p:nvGrpSpPr>
+      <p:grpSpPr/>
+      <p:sp>
+        <p:nvSpPr>
+          <p:cNvPr id="2" name="Oval 1"/>
+          <p:cNvSpPr/>
+          <p:nvPr/>
+        </p:nvSpPr>
+        <p:spPr>
+          <a:xfrm>
+            <a:off x="8961120" y="3200400"/>
+            <a:ext cx="5486400" cy="5486400"/>
+          </a:xfrm>
+          <a:prstGeom prst="ellipse">
+            <a:avLst/>
+          </a:prstGeom>
+          <a:solidFill>
+            <a:srgbClr val="4C7EFF">
+              <a:alpha val="10000"/>
+            </a:srgbClr>
+          </a:solidFill>
+          <a:ln>
+            <a:noFill/>
+          </a:ln>
+          <a:effectLst/>
+        </p:spPr>
+        <p:style>
+          <a:lnRef idx="1">
+            <a:schemeClr val="accent1"/>
+          </a:lnRef>
+          <a:fillRef idx="3">
+            <a:schemeClr val="accent1"/>
+          </a:fillRef>
+          <a:effectRef idx="2">
+            <a:schemeClr val="accent1"/>
+          </a:effectRef>
+          <a:fontRef idx="minor">
+            <a:schemeClr val="lt1"/>
+          </a:fontRef>
+        </p:style>
+        <p:txBody>
+          <a:bodyPr rtlCol="0" anchor="ctr"/>
+          <a:lstStyle/>
+          <a:p>
+            <a:pPr algn="ctr"/>
+          </a:p>
+        </p:txBody>
+      </p:sp>
+      <p:sp>
+        <p:nvSpPr>
           <p:cNvPr id="3" name="TextBox 2"/>
           <p:cNvSpPr txBox="1"/>
           <p:nvPr/>
@@ -4731,7 +5476,7 @@
                 </a:solidFill>
                 <a:latin typeface="Arial"/>
               </a:rPr>
-              <a:t>06</a:t>
+              <a:t>07</a:t>
             </a:r>
           </a:p>
         </p:txBody>

</xml_diff>